<commit_message>
Update to the new retreat logo; add dev/logo_to_svg.py
The conversion (PDF text to vector outlines, tight crop, slate color) is now a
script, so future logo updates are one command.

Co-Authored-By: Claude Opus 5.5 <noreply@anthropic.com>
</commit_message>
<xml_diff>
--- a/retreat_logo.pptx
+++ b/retreat_logo.pptx
@@ -104,6 +104,11 @@
       </a:defRPr>
     </a:lvl9pPr>
   </p:defaultTextStyle>
+  <p:extLst>
+    <p:ext uri="{EFAFB233-063F-42B5-8137-9DF3F51BA10A}">
+      <p15:sldGuideLst xmlns:p15="http://schemas.microsoft.com/office/powerpoint/2012/main"/>
+    </p:ext>
+  </p:extLst>
 </p:presentation>
 </file>
 
@@ -3434,8 +3439,8 @@
         </p:nvSpPr>
         <p:spPr>
           <a:xfrm>
-            <a:off x="5327127" y="2585477"/>
-            <a:ext cx="1767215" cy="830997"/>
+            <a:off x="5364705" y="2585477"/>
+            <a:ext cx="2143985" cy="830997"/>
           </a:xfrm>
           <a:prstGeom prst="rect">
             <a:avLst/>
@@ -3463,6 +3468,22 @@
                 <a:cs typeface="ADLaM Display" panose="02010000000000000000" pitchFamily="2" charset="77"/>
               </a:rPr>
               <a:t>etreat</a:t>
+            </a:r>
+            <a:r>
+              <a:rPr lang="en-IL" sz="2400" dirty="0">
+                <a:latin typeface="ADLaM Display" panose="02010000000000000000" pitchFamily="2" charset="77"/>
+                <a:ea typeface="ADLaM Display" panose="02010000000000000000" pitchFamily="2" charset="77"/>
+                <a:cs typeface="ADLaM Display" panose="02010000000000000000" pitchFamily="2" charset="77"/>
+              </a:rPr>
+              <a:t> </a:t>
+            </a:r>
+            <a:r>
+              <a:rPr lang="en-IL" dirty="0">
+                <a:latin typeface="ADLaM Display" panose="02010000000000000000" pitchFamily="2" charset="77"/>
+                <a:ea typeface="ADLaM Display" panose="02010000000000000000" pitchFamily="2" charset="77"/>
+                <a:cs typeface="ADLaM Display" panose="02010000000000000000" pitchFamily="2" charset="77"/>
+              </a:rPr>
+              <a:t>Jr.</a:t>
             </a:r>
           </a:p>
         </p:txBody>

</xml_diff>